<commit_message>
Add Elizabeth Anokhina & Zlata Sharvarok; 8-creator 4x2 roster
Grow the roster to eight creators (Elizabeth Anokhina 45M headliner and
Zlata Sharvarok 1M added), switch the roster slide to a dynamic 4+4 grid,
refresh Eli Vasilenko's and Zlata's photos, and update the numbers slide
to 79M+ combined audience across 8 featured creators.

Co-Authored-By: Claude Opus 4.8 <noreply@anthropic.com>
Claude-Session: https://claude.ai/code/session_01NjsWafkK96Zyh3RsVnh8un
</commit_message>
<xml_diff>
--- a/AS-Talent-Agency.pptx
+++ b/AS-Talent-Agency.pptx
@@ -2584,7 +2584,7 @@
       </p:sp>
       <p:pic>
         <p:nvPicPr>
-          <p:cNvPr id="4" name="Image 0" descr="/tmp/claude-0/-home-user-dasdsjfoisdjfoisj-github-io/f756b5b4-9ba5-5f42-afc2-0aa030ec1623/scratchpad/asdeck/assets/av-eli.png">    </p:cNvPr>
+          <p:cNvPr id="4" name="Image 0" descr="/tmp/claude-0/-home-user-dasdsjfoisdjfoisj-github-io/f756b5b4-9ba5-5f42-afc2-0aa030ec1623/scratchpad/asdeck/assets/av-elizabeth.png">    </p:cNvPr>
           <p:cNvPicPr>
             <a:picLocks noChangeAspect="1"/>
           </p:cNvPicPr>
@@ -2598,8 +2598,8 @@
         </p:blipFill>
         <p:spPr>
           <a:xfrm>
-            <a:off x="2025396" y="1508760"/>
-            <a:ext cx="1234440" cy="1234440"/>
+            <a:off x="1615402" y="1417320"/>
+            <a:ext cx="1051560" cy="1051560"/>
           </a:xfrm>
           <a:prstGeom prst="rect">
             <a:avLst/>
@@ -2614,8 +2614,50 @@
         </p:nvSpPr>
         <p:spPr>
           <a:xfrm>
-            <a:off x="950976" y="2816352"/>
-            <a:ext cx="3383280" cy="365760"/>
+            <a:off x="822960" y="2514600"/>
+            <a:ext cx="2636444" cy="457200"/>
+          </a:xfrm>
+          <a:prstGeom prst="rect">
+            <a:avLst/>
+          </a:prstGeom>
+          <a:noFill/>
+          <a:ln/>
+        </p:spPr>
+        <p:txBody>
+          <a:bodyPr wrap="square" rtlCol="0" anchor="t"/>
+          <a:lstStyle/>
+          <a:p>
+            <a:pPr algn="ctr" indent="0" marL="0">
+              <a:lnSpc>
+                <a:spcPct val="100000"/>
+              </a:lnSpc>
+              <a:buNone/>
+            </a:pPr>
+            <a:r>
+              <a:rPr lang="en-US" sz="1300" b="1" dirty="0">
+                <a:solidFill>
+                  <a:srgbClr val="FF3EA5"/>
+                </a:solidFill>
+                <a:latin typeface="Arial" pitchFamily="34" charset="0"/>
+                <a:ea typeface="Arial" pitchFamily="34" charset="-122"/>
+                <a:cs typeface="Arial" pitchFamily="34" charset="-120"/>
+              </a:rPr>
+              <a:t>ELIZABETH ANOKHINA</a:t>
+            </a:r>
+            <a:endParaRPr lang="en-US" sz="1300" dirty="0"/>
+          </a:p>
+        </p:txBody>
+      </p:sp>
+      <p:sp>
+        <p:nvSpPr>
+          <p:cNvPr id="6" name="Text 3"/>
+          <p:cNvSpPr/>
+          <p:nvPr/>
+        </p:nvSpPr>
+        <p:spPr>
+          <a:xfrm>
+            <a:off x="822960" y="3017520"/>
+            <a:ext cx="2636444" cy="274320"/>
           </a:xfrm>
           <a:prstGeom prst="rect">
             <a:avLst/>
@@ -2631,46 +2673,7 @@
               <a:buNone/>
             </a:pPr>
             <a:r>
-              <a:rPr lang="en-US" sz="1500" b="1" dirty="0">
-                <a:solidFill>
-                  <a:srgbClr val="FF3EA5"/>
-                </a:solidFill>
-                <a:latin typeface="Arial" pitchFamily="34" charset="0"/>
-                <a:ea typeface="Arial" pitchFamily="34" charset="-122"/>
-                <a:cs typeface="Arial" pitchFamily="34" charset="-120"/>
-              </a:rPr>
-              <a:t>ELI VASILENKO</a:t>
-            </a:r>
-            <a:endParaRPr lang="en-US" sz="1500" dirty="0"/>
-          </a:p>
-        </p:txBody>
-      </p:sp>
-      <p:sp>
-        <p:nvSpPr>
-          <p:cNvPr id="6" name="Text 3"/>
-          <p:cNvSpPr/>
-          <p:nvPr/>
-        </p:nvSpPr>
-        <p:spPr>
-          <a:xfrm>
-            <a:off x="950976" y="3200400"/>
-            <a:ext cx="3383280" cy="274320"/>
-          </a:xfrm>
-          <a:prstGeom prst="rect">
-            <a:avLst/>
-          </a:prstGeom>
-          <a:noFill/>
-          <a:ln/>
-        </p:spPr>
-        <p:txBody>
-          <a:bodyPr wrap="square" rtlCol="0" anchor="ctr"/>
-          <a:lstStyle/>
-          <a:p>
-            <a:pPr algn="ctr" indent="0" marL="0">
-              <a:buNone/>
-            </a:pPr>
-            <a:r>
-              <a:rPr lang="en-US" sz="1050" spc="100" kern="0" dirty="0">
+              <a:rPr lang="en-US" sz="1000" spc="100" kern="0" dirty="0">
                 <a:solidFill>
                   <a:srgbClr val="A6A6AE"/>
                 </a:solidFill>
@@ -2678,9 +2681,9 @@
                 <a:ea typeface="Arial" pitchFamily="34" charset="-122"/>
                 <a:cs typeface="Arial" pitchFamily="34" charset="-120"/>
               </a:rPr>
-              <a:t>10.5M FOLLOWERS</a:t>
-            </a:r>
-            <a:endParaRPr lang="en-US" sz="1050" dirty="0"/>
+              <a:t>45M FOLLOWERS</a:t>
+            </a:r>
+            <a:endParaRPr lang="en-US" sz="1000" dirty="0"/>
           </a:p>
         </p:txBody>
       </p:sp>
@@ -2692,8 +2695,8 @@
         </p:nvSpPr>
         <p:spPr>
           <a:xfrm>
-            <a:off x="2029968" y="3529584"/>
-            <a:ext cx="310896" cy="310896"/>
+            <a:off x="1601686" y="3337560"/>
+            <a:ext cx="274320" cy="274320"/>
           </a:xfrm>
           <a:prstGeom prst="ellipse">
             <a:avLst/>
@@ -2720,8 +2723,8 @@
         </p:blipFill>
         <p:spPr>
           <a:xfrm>
-            <a:off x="2098548" y="3598164"/>
-            <a:ext cx="173736" cy="173736"/>
+            <a:off x="1661122" y="3396996"/>
+            <a:ext cx="155448" cy="155448"/>
           </a:xfrm>
           <a:prstGeom prst="rect">
             <a:avLst/>
@@ -2736,8 +2739,8 @@
         </p:nvSpPr>
         <p:spPr>
           <a:xfrm>
-            <a:off x="2487168" y="3529584"/>
-            <a:ext cx="310896" cy="310896"/>
+            <a:off x="2004022" y="3337560"/>
+            <a:ext cx="274320" cy="274320"/>
           </a:xfrm>
           <a:prstGeom prst="ellipse">
             <a:avLst/>
@@ -2764,8 +2767,8 @@
         </p:blipFill>
         <p:spPr>
           <a:xfrm>
-            <a:off x="2555748" y="3598164"/>
-            <a:ext cx="173736" cy="173736"/>
+            <a:off x="2063458" y="3396996"/>
+            <a:ext cx="155448" cy="155448"/>
           </a:xfrm>
           <a:prstGeom prst="rect">
             <a:avLst/>
@@ -2780,8 +2783,8 @@
         </p:nvSpPr>
         <p:spPr>
           <a:xfrm>
-            <a:off x="2944368" y="3529584"/>
-            <a:ext cx="310896" cy="310896"/>
+            <a:off x="2406358" y="3337560"/>
+            <a:ext cx="274320" cy="274320"/>
           </a:xfrm>
           <a:prstGeom prst="ellipse">
             <a:avLst/>
@@ -2808,8 +2811,8 @@
         </p:blipFill>
         <p:spPr>
           <a:xfrm>
-            <a:off x="3012948" y="3598164"/>
-            <a:ext cx="173736" cy="173736"/>
+            <a:off x="2465794" y="3396996"/>
+            <a:ext cx="155448" cy="155448"/>
           </a:xfrm>
           <a:prstGeom prst="rect">
             <a:avLst/>
@@ -2818,7 +2821,7 @@
       </p:pic>
       <p:pic>
         <p:nvPicPr>
-          <p:cNvPr id="13" name="Image 4" descr="/tmp/claude-0/-home-user-dasdsjfoisdjfoisj-github-io/f756b5b4-9ba5-5f42-afc2-0aa030ec1623/scratchpad/asdeck/assets/av-caprice.png">    </p:cNvPr>
+          <p:cNvPr id="13" name="Image 4" descr="/tmp/claude-0/-home-user-dasdsjfoisdjfoisj-github-io/f756b5b4-9ba5-5f42-afc2-0aa030ec1623/scratchpad/asdeck/assets/av-eli.png">    </p:cNvPr>
           <p:cNvPicPr>
             <a:picLocks noChangeAspect="1"/>
           </p:cNvPicPr>
@@ -2832,8 +2835,8 @@
         </p:blipFill>
         <p:spPr>
           <a:xfrm>
-            <a:off x="5479085" y="1508760"/>
-            <a:ext cx="1234440" cy="1234440"/>
+            <a:off x="4251846" y="1417320"/>
+            <a:ext cx="1051560" cy="1051560"/>
           </a:xfrm>
           <a:prstGeom prst="rect">
             <a:avLst/>
@@ -2848,8 +2851,50 @@
         </p:nvSpPr>
         <p:spPr>
           <a:xfrm>
-            <a:off x="4404665" y="2816352"/>
-            <a:ext cx="3383280" cy="365760"/>
+            <a:off x="3459404" y="2514600"/>
+            <a:ext cx="2636444" cy="457200"/>
+          </a:xfrm>
+          <a:prstGeom prst="rect">
+            <a:avLst/>
+          </a:prstGeom>
+          <a:noFill/>
+          <a:ln/>
+        </p:spPr>
+        <p:txBody>
+          <a:bodyPr wrap="square" rtlCol="0" anchor="t"/>
+          <a:lstStyle/>
+          <a:p>
+            <a:pPr algn="ctr" indent="0" marL="0">
+              <a:lnSpc>
+                <a:spcPct val="100000"/>
+              </a:lnSpc>
+              <a:buNone/>
+            </a:pPr>
+            <a:r>
+              <a:rPr lang="en-US" sz="1300" b="1" dirty="0">
+                <a:solidFill>
+                  <a:srgbClr val="FF3EA5"/>
+                </a:solidFill>
+                <a:latin typeface="Arial" pitchFamily="34" charset="0"/>
+                <a:ea typeface="Arial" pitchFamily="34" charset="-122"/>
+                <a:cs typeface="Arial" pitchFamily="34" charset="-120"/>
+              </a:rPr>
+              <a:t>ELI VASILENKO</a:t>
+            </a:r>
+            <a:endParaRPr lang="en-US" sz="1300" dirty="0"/>
+          </a:p>
+        </p:txBody>
+      </p:sp>
+      <p:sp>
+        <p:nvSpPr>
+          <p:cNvPr id="15" name="Text 8"/>
+          <p:cNvSpPr/>
+          <p:nvPr/>
+        </p:nvSpPr>
+        <p:spPr>
+          <a:xfrm>
+            <a:off x="3459404" y="3017520"/>
+            <a:ext cx="2636444" cy="274320"/>
           </a:xfrm>
           <a:prstGeom prst="rect">
             <a:avLst/>
@@ -2865,46 +2910,7 @@
               <a:buNone/>
             </a:pPr>
             <a:r>
-              <a:rPr lang="en-US" sz="1500" b="1" dirty="0">
-                <a:solidFill>
-                  <a:srgbClr val="FF3EA5"/>
-                </a:solidFill>
-                <a:latin typeface="Arial" pitchFamily="34" charset="0"/>
-                <a:ea typeface="Arial" pitchFamily="34" charset="-122"/>
-                <a:cs typeface="Arial" pitchFamily="34" charset="-120"/>
-              </a:rPr>
-              <a:t>LITTLE CAPRICE</a:t>
-            </a:r>
-            <a:endParaRPr lang="en-US" sz="1500" dirty="0"/>
-          </a:p>
-        </p:txBody>
-      </p:sp>
-      <p:sp>
-        <p:nvSpPr>
-          <p:cNvPr id="15" name="Text 8"/>
-          <p:cNvSpPr/>
-          <p:nvPr/>
-        </p:nvSpPr>
-        <p:spPr>
-          <a:xfrm>
-            <a:off x="4404665" y="3200400"/>
-            <a:ext cx="3383280" cy="274320"/>
-          </a:xfrm>
-          <a:prstGeom prst="rect">
-            <a:avLst/>
-          </a:prstGeom>
-          <a:noFill/>
-          <a:ln/>
-        </p:spPr>
-        <p:txBody>
-          <a:bodyPr wrap="square" rtlCol="0" anchor="ctr"/>
-          <a:lstStyle/>
-          <a:p>
-            <a:pPr algn="ctr" indent="0" marL="0">
-              <a:buNone/>
-            </a:pPr>
-            <a:r>
-              <a:rPr lang="en-US" sz="1050" spc="100" kern="0" dirty="0">
+              <a:rPr lang="en-US" sz="1000" spc="100" kern="0" dirty="0">
                 <a:solidFill>
                   <a:srgbClr val="A6A6AE"/>
                 </a:solidFill>
@@ -2912,9 +2918,9 @@
                 <a:ea typeface="Arial" pitchFamily="34" charset="-122"/>
                 <a:cs typeface="Arial" pitchFamily="34" charset="-120"/>
               </a:rPr>
-              <a:t>11M FOLLOWERS</a:t>
-            </a:r>
-            <a:endParaRPr lang="en-US" sz="1050" dirty="0"/>
+              <a:t>10.5M FOLLOWERS</a:t>
+            </a:r>
+            <a:endParaRPr lang="en-US" sz="1000" dirty="0"/>
           </a:p>
         </p:txBody>
       </p:sp>
@@ -2926,8 +2932,8 @@
         </p:nvSpPr>
         <p:spPr>
           <a:xfrm>
-            <a:off x="5712257" y="3529584"/>
-            <a:ext cx="310896" cy="310896"/>
+            <a:off x="4238130" y="3337560"/>
+            <a:ext cx="274320" cy="274320"/>
           </a:xfrm>
           <a:prstGeom prst="ellipse">
             <a:avLst/>
@@ -2940,7 +2946,7 @@
       </p:sp>
       <p:pic>
         <p:nvPicPr>
-          <p:cNvPr id="17" name="Image 5" descr="/tmp/claude-0/-home-user-dasdsjfoisdjfoisj-github-io/f756b5b4-9ba5-5f42-afc2-0aa030ec1623/scratchpad/asdeck/assets/ic-tiktok.png">    </p:cNvPr>
+          <p:cNvPr id="17" name="Image 5" descr="/tmp/claude-0/-home-user-dasdsjfoisdjfoisj-github-io/f756b5b4-9ba5-5f42-afc2-0aa030ec1623/scratchpad/asdeck/assets/ic-x.png">    </p:cNvPr>
           <p:cNvPicPr>
             <a:picLocks noChangeAspect="1"/>
           </p:cNvPicPr>
@@ -2954,8 +2960,8 @@
         </p:blipFill>
         <p:spPr>
           <a:xfrm>
-            <a:off x="5780837" y="3598164"/>
-            <a:ext cx="173736" cy="173736"/>
+            <a:off x="4297566" y="3396996"/>
+            <a:ext cx="155448" cy="155448"/>
           </a:xfrm>
           <a:prstGeom prst="rect">
             <a:avLst/>
@@ -2970,8 +2976,8 @@
         </p:nvSpPr>
         <p:spPr>
           <a:xfrm>
-            <a:off x="6169457" y="3529584"/>
-            <a:ext cx="310896" cy="310896"/>
+            <a:off x="4640466" y="3337560"/>
+            <a:ext cx="274320" cy="274320"/>
           </a:xfrm>
           <a:prstGeom prst="ellipse">
             <a:avLst/>
@@ -2984,7 +2990,7 @@
       </p:sp>
       <p:pic>
         <p:nvPicPr>
-          <p:cNvPr id="19" name="Image 6" descr="/tmp/claude-0/-home-user-dasdsjfoisdjfoisj-github-io/f756b5b4-9ba5-5f42-afc2-0aa030ec1623/scratchpad/asdeck/assets/ic-instagram.png">    </p:cNvPr>
+          <p:cNvPr id="19" name="Image 6" descr="/tmp/claude-0/-home-user-dasdsjfoisdjfoisj-github-io/f756b5b4-9ba5-5f42-afc2-0aa030ec1623/scratchpad/asdeck/assets/ic-tiktok.png">    </p:cNvPr>
           <p:cNvPicPr>
             <a:picLocks noChangeAspect="1"/>
           </p:cNvPicPr>
@@ -2998,17 +3004,37 @@
         </p:blipFill>
         <p:spPr>
           <a:xfrm>
-            <a:off x="6238037" y="3598164"/>
-            <a:ext cx="173736" cy="173736"/>
+            <a:off x="4699902" y="3396996"/>
+            <a:ext cx="155448" cy="155448"/>
           </a:xfrm>
           <a:prstGeom prst="rect">
             <a:avLst/>
           </a:prstGeom>
         </p:spPr>
       </p:pic>
+      <p:sp>
+        <p:nvSpPr>
+          <p:cNvPr id="20" name="Shape 11"/>
+          <p:cNvSpPr/>
+          <p:nvPr/>
+        </p:nvSpPr>
+        <p:spPr>
+          <a:xfrm>
+            <a:off x="5042802" y="3337560"/>
+            <a:ext cx="274320" cy="274320"/>
+          </a:xfrm>
+          <a:prstGeom prst="ellipse">
+            <a:avLst/>
+          </a:prstGeom>
+          <a:solidFill>
+            <a:srgbClr val="F2F2F2"/>
+          </a:solidFill>
+          <a:ln/>
+        </p:spPr>
+      </p:sp>
       <p:pic>
         <p:nvPicPr>
-          <p:cNvPr id="20" name="Image 7" descr="/tmp/claude-0/-home-user-dasdsjfoisdjfoisj-github-io/f756b5b4-9ba5-5f42-afc2-0aa030ec1623/scratchpad/asdeck/assets/av-macca.png">    </p:cNvPr>
+          <p:cNvPr id="21" name="Image 7" descr="/tmp/claude-0/-home-user-dasdsjfoisdjfoisj-github-io/f756b5b4-9ba5-5f42-afc2-0aa030ec1623/scratchpad/asdeck/assets/ic-instagram.png">    </p:cNvPr>
           <p:cNvPicPr>
             <a:picLocks noChangeAspect="1"/>
           </p:cNvPicPr>
@@ -3022,115 +3048,17 @@
         </p:blipFill>
         <p:spPr>
           <a:xfrm>
-            <a:off x="8929116" y="1508760"/>
-            <a:ext cx="1234440" cy="1234440"/>
+            <a:off x="5102238" y="3396996"/>
+            <a:ext cx="155448" cy="155448"/>
           </a:xfrm>
           <a:prstGeom prst="rect">
             <a:avLst/>
           </a:prstGeom>
         </p:spPr>
       </p:pic>
-      <p:sp>
-        <p:nvSpPr>
-          <p:cNvPr id="21" name="Text 11"/>
-          <p:cNvSpPr/>
-          <p:nvPr/>
-        </p:nvSpPr>
-        <p:spPr>
-          <a:xfrm>
-            <a:off x="7854696" y="2816352"/>
-            <a:ext cx="3383280" cy="365760"/>
-          </a:xfrm>
-          <a:prstGeom prst="rect">
-            <a:avLst/>
-          </a:prstGeom>
-          <a:noFill/>
-          <a:ln/>
-        </p:spPr>
-        <p:txBody>
-          <a:bodyPr wrap="square" rtlCol="0" anchor="ctr"/>
-          <a:lstStyle/>
-          <a:p>
-            <a:pPr algn="ctr" indent="0" marL="0">
-              <a:buNone/>
-            </a:pPr>
-            <a:r>
-              <a:rPr lang="en-US" sz="1500" b="1" dirty="0">
-                <a:solidFill>
-                  <a:srgbClr val="FF3EA5"/>
-                </a:solidFill>
-                <a:latin typeface="Arial" pitchFamily="34" charset="0"/>
-                <a:ea typeface="Arial" pitchFamily="34" charset="-122"/>
-                <a:cs typeface="Arial" pitchFamily="34" charset="-120"/>
-              </a:rPr>
-              <a:t>MACCA</a:t>
-            </a:r>
-            <a:endParaRPr lang="en-US" sz="1500" dirty="0"/>
-          </a:p>
-        </p:txBody>
-      </p:sp>
-      <p:sp>
-        <p:nvSpPr>
-          <p:cNvPr id="22" name="Text 12"/>
-          <p:cNvSpPr/>
-          <p:nvPr/>
-        </p:nvSpPr>
-        <p:spPr>
-          <a:xfrm>
-            <a:off x="7854696" y="3200400"/>
-            <a:ext cx="3383280" cy="274320"/>
-          </a:xfrm>
-          <a:prstGeom prst="rect">
-            <a:avLst/>
-          </a:prstGeom>
-          <a:noFill/>
-          <a:ln/>
-        </p:spPr>
-        <p:txBody>
-          <a:bodyPr wrap="square" rtlCol="0" anchor="ctr"/>
-          <a:lstStyle/>
-          <a:p>
-            <a:pPr algn="ctr" indent="0" marL="0">
-              <a:buNone/>
-            </a:pPr>
-            <a:r>
-              <a:rPr lang="en-US" sz="1050" spc="100" kern="0" dirty="0">
-                <a:solidFill>
-                  <a:srgbClr val="A6A6AE"/>
-                </a:solidFill>
-                <a:latin typeface="Arial" pitchFamily="34" charset="0"/>
-                <a:ea typeface="Arial" pitchFamily="34" charset="-122"/>
-                <a:cs typeface="Arial" pitchFamily="34" charset="-120"/>
-              </a:rPr>
-              <a:t>1.5M FOLLOWERS</a:t>
-            </a:r>
-            <a:endParaRPr lang="en-US" sz="1050" dirty="0"/>
-          </a:p>
-        </p:txBody>
-      </p:sp>
-      <p:sp>
-        <p:nvSpPr>
-          <p:cNvPr id="23" name="Shape 13"/>
-          <p:cNvSpPr/>
-          <p:nvPr/>
-        </p:nvSpPr>
-        <p:spPr>
-          <a:xfrm>
-            <a:off x="8933688" y="3529584"/>
-            <a:ext cx="310896" cy="310896"/>
-          </a:xfrm>
-          <a:prstGeom prst="ellipse">
-            <a:avLst/>
-          </a:prstGeom>
-          <a:solidFill>
-            <a:srgbClr val="F2F2F2"/>
-          </a:solidFill>
-          <a:ln/>
-        </p:spPr>
-      </p:sp>
       <p:pic>
         <p:nvPicPr>
-          <p:cNvPr id="24" name="Image 8" descr="/tmp/claude-0/-home-user-dasdsjfoisdjfoisj-github-io/f756b5b4-9ba5-5f42-afc2-0aa030ec1623/scratchpad/asdeck/assets/ic-x.png">    </p:cNvPr>
+          <p:cNvPr id="22" name="Image 8" descr="/tmp/claude-0/-home-user-dasdsjfoisdjfoisj-github-io/f756b5b4-9ba5-5f42-afc2-0aa030ec1623/scratchpad/asdeck/assets/av-caprice.png">    </p:cNvPr>
           <p:cNvPicPr>
             <a:picLocks noChangeAspect="1"/>
           </p:cNvPicPr>
@@ -3144,8 +3072,8 @@
         </p:blipFill>
         <p:spPr>
           <a:xfrm>
-            <a:off x="9002268" y="3598164"/>
-            <a:ext cx="173736" cy="173736"/>
+            <a:off x="6888289" y="1417320"/>
+            <a:ext cx="1051560" cy="1051560"/>
           </a:xfrm>
           <a:prstGeom prst="rect">
             <a:avLst/>
@@ -3154,14 +3082,95 @@
       </p:pic>
       <p:sp>
         <p:nvSpPr>
+          <p:cNvPr id="23" name="Text 12"/>
+          <p:cNvSpPr/>
+          <p:nvPr/>
+        </p:nvSpPr>
+        <p:spPr>
+          <a:xfrm>
+            <a:off x="6095848" y="2514600"/>
+            <a:ext cx="2636444" cy="457200"/>
+          </a:xfrm>
+          <a:prstGeom prst="rect">
+            <a:avLst/>
+          </a:prstGeom>
+          <a:noFill/>
+          <a:ln/>
+        </p:spPr>
+        <p:txBody>
+          <a:bodyPr wrap="square" rtlCol="0" anchor="t"/>
+          <a:lstStyle/>
+          <a:p>
+            <a:pPr algn="ctr" indent="0" marL="0">
+              <a:lnSpc>
+                <a:spcPct val="100000"/>
+              </a:lnSpc>
+              <a:buNone/>
+            </a:pPr>
+            <a:r>
+              <a:rPr lang="en-US" sz="1300" b="1" dirty="0">
+                <a:solidFill>
+                  <a:srgbClr val="FF3EA5"/>
+                </a:solidFill>
+                <a:latin typeface="Arial" pitchFamily="34" charset="0"/>
+                <a:ea typeface="Arial" pitchFamily="34" charset="-122"/>
+                <a:cs typeface="Arial" pitchFamily="34" charset="-120"/>
+              </a:rPr>
+              <a:t>LITTLE CAPRICE</a:t>
+            </a:r>
+            <a:endParaRPr lang="en-US" sz="1300" dirty="0"/>
+          </a:p>
+        </p:txBody>
+      </p:sp>
+      <p:sp>
+        <p:nvSpPr>
+          <p:cNvPr id="24" name="Text 13"/>
+          <p:cNvSpPr/>
+          <p:nvPr/>
+        </p:nvSpPr>
+        <p:spPr>
+          <a:xfrm>
+            <a:off x="6095848" y="3017520"/>
+            <a:ext cx="2636444" cy="274320"/>
+          </a:xfrm>
+          <a:prstGeom prst="rect">
+            <a:avLst/>
+          </a:prstGeom>
+          <a:noFill/>
+          <a:ln/>
+        </p:spPr>
+        <p:txBody>
+          <a:bodyPr wrap="square" rtlCol="0" anchor="ctr"/>
+          <a:lstStyle/>
+          <a:p>
+            <a:pPr algn="ctr" indent="0" marL="0">
+              <a:buNone/>
+            </a:pPr>
+            <a:r>
+              <a:rPr lang="en-US" sz="1000" spc="100" kern="0" dirty="0">
+                <a:solidFill>
+                  <a:srgbClr val="A6A6AE"/>
+                </a:solidFill>
+                <a:latin typeface="Arial" pitchFamily="34" charset="0"/>
+                <a:ea typeface="Arial" pitchFamily="34" charset="-122"/>
+                <a:cs typeface="Arial" pitchFamily="34" charset="-120"/>
+              </a:rPr>
+              <a:t>11M FOLLOWERS</a:t>
+            </a:r>
+            <a:endParaRPr lang="en-US" sz="1000" dirty="0"/>
+          </a:p>
+        </p:txBody>
+      </p:sp>
+      <p:sp>
+        <p:nvSpPr>
           <p:cNvPr id="25" name="Shape 14"/>
           <p:cNvSpPr/>
           <p:nvPr/>
         </p:nvSpPr>
         <p:spPr>
           <a:xfrm>
-            <a:off x="9390888" y="3529584"/>
-            <a:ext cx="310896" cy="310896"/>
+            <a:off x="7075741" y="3337560"/>
+            <a:ext cx="274320" cy="274320"/>
           </a:xfrm>
           <a:prstGeom prst="ellipse">
             <a:avLst/>
@@ -3188,8 +3197,8 @@
         </p:blipFill>
         <p:spPr>
           <a:xfrm>
-            <a:off x="9459468" y="3598164"/>
-            <a:ext cx="173736" cy="173736"/>
+            <a:off x="7135178" y="3396996"/>
+            <a:ext cx="155448" cy="155448"/>
           </a:xfrm>
           <a:prstGeom prst="rect">
             <a:avLst/>
@@ -3204,8 +3213,8 @@
         </p:nvSpPr>
         <p:spPr>
           <a:xfrm>
-            <a:off x="9848088" y="3529584"/>
-            <a:ext cx="310896" cy="310896"/>
+            <a:off x="7478078" y="3337560"/>
+            <a:ext cx="274320" cy="274320"/>
           </a:xfrm>
           <a:prstGeom prst="ellipse">
             <a:avLst/>
@@ -3232,8 +3241,8 @@
         </p:blipFill>
         <p:spPr>
           <a:xfrm>
-            <a:off x="9916668" y="3598164"/>
-            <a:ext cx="173736" cy="173736"/>
+            <a:off x="7537513" y="3396996"/>
+            <a:ext cx="155448" cy="155448"/>
           </a:xfrm>
           <a:prstGeom prst="rect">
             <a:avLst/>
@@ -3242,7 +3251,7 @@
       </p:pic>
       <p:pic>
         <p:nvPicPr>
-          <p:cNvPr id="29" name="Image 11" descr="/tmp/claude-0/-home-user-dasdsjfoisdjfoisj-github-io/f756b5b4-9ba5-5f42-afc2-0aa030ec1623/scratchpad/asdeck/assets/av-kuri.png">    </p:cNvPr>
+          <p:cNvPr id="29" name="Image 11" descr="/tmp/claude-0/-home-user-dasdsjfoisdjfoisj-github-io/f756b5b4-9ba5-5f42-afc2-0aa030ec1623/scratchpad/asdeck/assets/av-macca.png">    </p:cNvPr>
           <p:cNvPicPr>
             <a:picLocks noChangeAspect="1"/>
           </p:cNvPicPr>
@@ -3256,8 +3265,8 @@
         </p:blipFill>
         <p:spPr>
           <a:xfrm>
-            <a:off x="2025396" y="4114800"/>
-            <a:ext cx="1234440" cy="1234440"/>
+            <a:off x="9524733" y="1417320"/>
+            <a:ext cx="1051560" cy="1051560"/>
           </a:xfrm>
           <a:prstGeom prst="rect">
             <a:avLst/>
@@ -3272,8 +3281,50 @@
         </p:nvSpPr>
         <p:spPr>
           <a:xfrm>
-            <a:off x="950976" y="5422392"/>
-            <a:ext cx="3383280" cy="365760"/>
+            <a:off x="8732291" y="2514600"/>
+            <a:ext cx="2636444" cy="457200"/>
+          </a:xfrm>
+          <a:prstGeom prst="rect">
+            <a:avLst/>
+          </a:prstGeom>
+          <a:noFill/>
+          <a:ln/>
+        </p:spPr>
+        <p:txBody>
+          <a:bodyPr wrap="square" rtlCol="0" anchor="t"/>
+          <a:lstStyle/>
+          <a:p>
+            <a:pPr algn="ctr" indent="0" marL="0">
+              <a:lnSpc>
+                <a:spcPct val="100000"/>
+              </a:lnSpc>
+              <a:buNone/>
+            </a:pPr>
+            <a:r>
+              <a:rPr lang="en-US" sz="1300" b="1" dirty="0">
+                <a:solidFill>
+                  <a:srgbClr val="FF3EA5"/>
+                </a:solidFill>
+                <a:latin typeface="Arial" pitchFamily="34" charset="0"/>
+                <a:ea typeface="Arial" pitchFamily="34" charset="-122"/>
+                <a:cs typeface="Arial" pitchFamily="34" charset="-120"/>
+              </a:rPr>
+              <a:t>MACCA</a:t>
+            </a:r>
+            <a:endParaRPr lang="en-US" sz="1300" dirty="0"/>
+          </a:p>
+        </p:txBody>
+      </p:sp>
+      <p:sp>
+        <p:nvSpPr>
+          <p:cNvPr id="31" name="Text 17"/>
+          <p:cNvSpPr/>
+          <p:nvPr/>
+        </p:nvSpPr>
+        <p:spPr>
+          <a:xfrm>
+            <a:off x="8732291" y="3017520"/>
+            <a:ext cx="2636444" cy="274320"/>
           </a:xfrm>
           <a:prstGeom prst="rect">
             <a:avLst/>
@@ -3289,46 +3340,7 @@
               <a:buNone/>
             </a:pPr>
             <a:r>
-              <a:rPr lang="en-US" sz="1500" b="1" dirty="0">
-                <a:solidFill>
-                  <a:srgbClr val="FF3EA5"/>
-                </a:solidFill>
-                <a:latin typeface="Arial" pitchFamily="34" charset="0"/>
-                <a:ea typeface="Arial" pitchFamily="34" charset="-122"/>
-                <a:cs typeface="Arial" pitchFamily="34" charset="-120"/>
-              </a:rPr>
-              <a:t>KURI EMI</a:t>
-            </a:r>
-            <a:endParaRPr lang="en-US" sz="1500" dirty="0"/>
-          </a:p>
-        </p:txBody>
-      </p:sp>
-      <p:sp>
-        <p:nvSpPr>
-          <p:cNvPr id="31" name="Text 17"/>
-          <p:cNvSpPr/>
-          <p:nvPr/>
-        </p:nvSpPr>
-        <p:spPr>
-          <a:xfrm>
-            <a:off x="950976" y="5806440"/>
-            <a:ext cx="3383280" cy="274320"/>
-          </a:xfrm>
-          <a:prstGeom prst="rect">
-            <a:avLst/>
-          </a:prstGeom>
-          <a:noFill/>
-          <a:ln/>
-        </p:spPr>
-        <p:txBody>
-          <a:bodyPr wrap="square" rtlCol="0" anchor="ctr"/>
-          <a:lstStyle/>
-          <a:p>
-            <a:pPr algn="ctr" indent="0" marL="0">
-              <a:buNone/>
-            </a:pPr>
-            <a:r>
-              <a:rPr lang="en-US" sz="1050" spc="100" kern="0" dirty="0">
+              <a:rPr lang="en-US" sz="1000" spc="100" kern="0" dirty="0">
                 <a:solidFill>
                   <a:srgbClr val="A6A6AE"/>
                 </a:solidFill>
@@ -3336,9 +3348,9 @@
                 <a:ea typeface="Arial" pitchFamily="34" charset="-122"/>
                 <a:cs typeface="Arial" pitchFamily="34" charset="-120"/>
               </a:rPr>
-              <a:t>2.5M FOLLOWERS</a:t>
-            </a:r>
-            <a:endParaRPr lang="en-US" sz="1050" dirty="0"/>
+              <a:t>1.5M FOLLOWERS</a:t>
+            </a:r>
+            <a:endParaRPr lang="en-US" sz="1000" dirty="0"/>
           </a:p>
         </p:txBody>
       </p:sp>
@@ -3350,8 +3362,8 @@
         </p:nvSpPr>
         <p:spPr>
           <a:xfrm>
-            <a:off x="2029968" y="6135624"/>
-            <a:ext cx="310896" cy="310896"/>
+            <a:off x="9511017" y="3337560"/>
+            <a:ext cx="274320" cy="274320"/>
           </a:xfrm>
           <a:prstGeom prst="ellipse">
             <a:avLst/>
@@ -3378,8 +3390,8 @@
         </p:blipFill>
         <p:spPr>
           <a:xfrm>
-            <a:off x="2098548" y="6204204"/>
-            <a:ext cx="173736" cy="173736"/>
+            <a:off x="9570453" y="3396996"/>
+            <a:ext cx="155448" cy="155448"/>
           </a:xfrm>
           <a:prstGeom prst="rect">
             <a:avLst/>
@@ -3394,8 +3406,8 @@
         </p:nvSpPr>
         <p:spPr>
           <a:xfrm>
-            <a:off x="2487168" y="6135624"/>
-            <a:ext cx="310896" cy="310896"/>
+            <a:off x="9913353" y="3337560"/>
+            <a:ext cx="274320" cy="274320"/>
           </a:xfrm>
           <a:prstGeom prst="ellipse">
             <a:avLst/>
@@ -3422,8 +3434,8 @@
         </p:blipFill>
         <p:spPr>
           <a:xfrm>
-            <a:off x="2555748" y="6204204"/>
-            <a:ext cx="173736" cy="173736"/>
+            <a:off x="9972789" y="3396996"/>
+            <a:ext cx="155448" cy="155448"/>
           </a:xfrm>
           <a:prstGeom prst="rect">
             <a:avLst/>
@@ -3438,8 +3450,8 @@
         </p:nvSpPr>
         <p:spPr>
           <a:xfrm>
-            <a:off x="2944368" y="6135624"/>
-            <a:ext cx="310896" cy="310896"/>
+            <a:off x="10315689" y="3337560"/>
+            <a:ext cx="274320" cy="274320"/>
           </a:xfrm>
           <a:prstGeom prst="ellipse">
             <a:avLst/>
@@ -3466,8 +3478,8 @@
         </p:blipFill>
         <p:spPr>
           <a:xfrm>
-            <a:off x="3012948" y="6204204"/>
-            <a:ext cx="173736" cy="173736"/>
+            <a:off x="10375125" y="3396996"/>
+            <a:ext cx="155448" cy="155448"/>
           </a:xfrm>
           <a:prstGeom prst="rect">
             <a:avLst/>
@@ -3476,7 +3488,7 @@
       </p:pic>
       <p:pic>
         <p:nvPicPr>
-          <p:cNvPr id="38" name="Image 15" descr="/tmp/claude-0/-home-user-dasdsjfoisdjfoisj-github-io/f756b5b4-9ba5-5f42-afc2-0aa030ec1623/scratchpad/asdeck/assets/av-qimmah.png">    </p:cNvPr>
+          <p:cNvPr id="38" name="Image 15" descr="/tmp/claude-0/-home-user-dasdsjfoisdjfoisj-github-io/f756b5b4-9ba5-5f42-afc2-0aa030ec1623/scratchpad/asdeck/assets/av-kuri.png">    </p:cNvPr>
           <p:cNvPicPr>
             <a:picLocks noChangeAspect="1"/>
           </p:cNvPicPr>
@@ -3490,8 +3502,8 @@
         </p:blipFill>
         <p:spPr>
           <a:xfrm>
-            <a:off x="5479085" y="4114800"/>
-            <a:ext cx="1234440" cy="1234440"/>
+            <a:off x="1615402" y="3977640"/>
+            <a:ext cx="1051560" cy="1051560"/>
           </a:xfrm>
           <a:prstGeom prst="rect">
             <a:avLst/>
@@ -3506,8 +3518,50 @@
         </p:nvSpPr>
         <p:spPr>
           <a:xfrm>
-            <a:off x="4404665" y="5422392"/>
-            <a:ext cx="3383280" cy="365760"/>
+            <a:off x="822960" y="5074920"/>
+            <a:ext cx="2636444" cy="457200"/>
+          </a:xfrm>
+          <a:prstGeom prst="rect">
+            <a:avLst/>
+          </a:prstGeom>
+          <a:noFill/>
+          <a:ln/>
+        </p:spPr>
+        <p:txBody>
+          <a:bodyPr wrap="square" rtlCol="0" anchor="t"/>
+          <a:lstStyle/>
+          <a:p>
+            <a:pPr algn="ctr" indent="0" marL="0">
+              <a:lnSpc>
+                <a:spcPct val="100000"/>
+              </a:lnSpc>
+              <a:buNone/>
+            </a:pPr>
+            <a:r>
+              <a:rPr lang="en-US" sz="1300" b="1" dirty="0">
+                <a:solidFill>
+                  <a:srgbClr val="FF3EA5"/>
+                </a:solidFill>
+                <a:latin typeface="Arial" pitchFamily="34" charset="0"/>
+                <a:ea typeface="Arial" pitchFamily="34" charset="-122"/>
+                <a:cs typeface="Arial" pitchFamily="34" charset="-120"/>
+              </a:rPr>
+              <a:t>KURI EMI</a:t>
+            </a:r>
+            <a:endParaRPr lang="en-US" sz="1300" dirty="0"/>
+          </a:p>
+        </p:txBody>
+      </p:sp>
+      <p:sp>
+        <p:nvSpPr>
+          <p:cNvPr id="40" name="Text 22"/>
+          <p:cNvSpPr/>
+          <p:nvPr/>
+        </p:nvSpPr>
+        <p:spPr>
+          <a:xfrm>
+            <a:off x="822960" y="5577840"/>
+            <a:ext cx="2636444" cy="274320"/>
           </a:xfrm>
           <a:prstGeom prst="rect">
             <a:avLst/>
@@ -3523,46 +3577,7 @@
               <a:buNone/>
             </a:pPr>
             <a:r>
-              <a:rPr lang="en-US" sz="1500" b="1" dirty="0">
-                <a:solidFill>
-                  <a:srgbClr val="FF3EA5"/>
-                </a:solidFill>
-                <a:latin typeface="Arial" pitchFamily="34" charset="0"/>
-                <a:ea typeface="Arial" pitchFamily="34" charset="-122"/>
-                <a:cs typeface="Arial" pitchFamily="34" charset="-120"/>
-              </a:rPr>
-              <a:t>QIMMAH RUSSO</a:t>
-            </a:r>
-            <a:endParaRPr lang="en-US" sz="1500" dirty="0"/>
-          </a:p>
-        </p:txBody>
-      </p:sp>
-      <p:sp>
-        <p:nvSpPr>
-          <p:cNvPr id="40" name="Text 22"/>
-          <p:cNvSpPr/>
-          <p:nvPr/>
-        </p:nvSpPr>
-        <p:spPr>
-          <a:xfrm>
-            <a:off x="4404665" y="5806440"/>
-            <a:ext cx="3383280" cy="274320"/>
-          </a:xfrm>
-          <a:prstGeom prst="rect">
-            <a:avLst/>
-          </a:prstGeom>
-          <a:noFill/>
-          <a:ln/>
-        </p:spPr>
-        <p:txBody>
-          <a:bodyPr wrap="square" rtlCol="0" anchor="ctr"/>
-          <a:lstStyle/>
-          <a:p>
-            <a:pPr algn="ctr" indent="0" marL="0">
-              <a:buNone/>
-            </a:pPr>
-            <a:r>
-              <a:rPr lang="en-US" sz="1050" spc="100" kern="0" dirty="0">
+              <a:rPr lang="en-US" sz="1000" spc="100" kern="0" dirty="0">
                 <a:solidFill>
                   <a:srgbClr val="A6A6AE"/>
                 </a:solidFill>
@@ -3570,9 +3585,9 @@
                 <a:ea typeface="Arial" pitchFamily="34" charset="-122"/>
                 <a:cs typeface="Arial" pitchFamily="34" charset="-120"/>
               </a:rPr>
-              <a:t>5M FOLLOWERS</a:t>
-            </a:r>
-            <a:endParaRPr lang="en-US" sz="1050" dirty="0"/>
+              <a:t>2.5M FOLLOWERS</a:t>
+            </a:r>
+            <a:endParaRPr lang="en-US" sz="1000" dirty="0"/>
           </a:p>
         </p:txBody>
       </p:sp>
@@ -3584,8 +3599,8 @@
         </p:nvSpPr>
         <p:spPr>
           <a:xfrm>
-            <a:off x="5483657" y="6135624"/>
-            <a:ext cx="310896" cy="310896"/>
+            <a:off x="1601686" y="5897880"/>
+            <a:ext cx="274320" cy="274320"/>
           </a:xfrm>
           <a:prstGeom prst="ellipse">
             <a:avLst/>
@@ -3612,8 +3627,8 @@
         </p:blipFill>
         <p:spPr>
           <a:xfrm>
-            <a:off x="5552237" y="6204204"/>
-            <a:ext cx="173736" cy="173736"/>
+            <a:off x="1661122" y="5957316"/>
+            <a:ext cx="155448" cy="155448"/>
           </a:xfrm>
           <a:prstGeom prst="rect">
             <a:avLst/>
@@ -3628,8 +3643,8 @@
         </p:nvSpPr>
         <p:spPr>
           <a:xfrm>
-            <a:off x="5940857" y="6135624"/>
-            <a:ext cx="310896" cy="310896"/>
+            <a:off x="2004022" y="5897880"/>
+            <a:ext cx="274320" cy="274320"/>
           </a:xfrm>
           <a:prstGeom prst="ellipse">
             <a:avLst/>
@@ -3656,8 +3671,8 @@
         </p:blipFill>
         <p:spPr>
           <a:xfrm>
-            <a:off x="6009437" y="6204204"/>
-            <a:ext cx="173736" cy="173736"/>
+            <a:off x="2063458" y="5957316"/>
+            <a:ext cx="155448" cy="155448"/>
           </a:xfrm>
           <a:prstGeom prst="rect">
             <a:avLst/>
@@ -3672,8 +3687,8 @@
         </p:nvSpPr>
         <p:spPr>
           <a:xfrm>
-            <a:off x="6398057" y="6135624"/>
-            <a:ext cx="310896" cy="310896"/>
+            <a:off x="2406358" y="5897880"/>
+            <a:ext cx="274320" cy="274320"/>
           </a:xfrm>
           <a:prstGeom prst="ellipse">
             <a:avLst/>
@@ -3700,8 +3715,8 @@
         </p:blipFill>
         <p:spPr>
           <a:xfrm>
-            <a:off x="6466637" y="6204204"/>
-            <a:ext cx="173736" cy="173736"/>
+            <a:off x="2465794" y="5957316"/>
+            <a:ext cx="155448" cy="155448"/>
           </a:xfrm>
           <a:prstGeom prst="rect">
             <a:avLst/>
@@ -3710,7 +3725,7 @@
       </p:pic>
       <p:pic>
         <p:nvPicPr>
-          <p:cNvPr id="47" name="Image 19" descr="/tmp/claude-0/-home-user-dasdsjfoisdjfoisj-github-io/f756b5b4-9ba5-5f42-afc2-0aa030ec1623/scratchpad/asdeck/assets/av-chloe.png">    </p:cNvPr>
+          <p:cNvPr id="47" name="Image 19" descr="/tmp/claude-0/-home-user-dasdsjfoisdjfoisj-github-io/f756b5b4-9ba5-5f42-afc2-0aa030ec1623/scratchpad/asdeck/assets/av-qimmah.png">    </p:cNvPr>
           <p:cNvPicPr>
             <a:picLocks noChangeAspect="1"/>
           </p:cNvPicPr>
@@ -3724,8 +3739,8 @@
         </p:blipFill>
         <p:spPr>
           <a:xfrm>
-            <a:off x="8929116" y="4114800"/>
-            <a:ext cx="1234440" cy="1234440"/>
+            <a:off x="4251846" y="3977640"/>
+            <a:ext cx="1051560" cy="1051560"/>
           </a:xfrm>
           <a:prstGeom prst="rect">
             <a:avLst/>
@@ -3740,8 +3755,50 @@
         </p:nvSpPr>
         <p:spPr>
           <a:xfrm>
-            <a:off x="7854696" y="5422392"/>
-            <a:ext cx="3383280" cy="365760"/>
+            <a:off x="3459404" y="5074920"/>
+            <a:ext cx="2636444" cy="457200"/>
+          </a:xfrm>
+          <a:prstGeom prst="rect">
+            <a:avLst/>
+          </a:prstGeom>
+          <a:noFill/>
+          <a:ln/>
+        </p:spPr>
+        <p:txBody>
+          <a:bodyPr wrap="square" rtlCol="0" anchor="t"/>
+          <a:lstStyle/>
+          <a:p>
+            <a:pPr algn="ctr" indent="0" marL="0">
+              <a:lnSpc>
+                <a:spcPct val="100000"/>
+              </a:lnSpc>
+              <a:buNone/>
+            </a:pPr>
+            <a:r>
+              <a:rPr lang="en-US" sz="1300" b="1" dirty="0">
+                <a:solidFill>
+                  <a:srgbClr val="FF3EA5"/>
+                </a:solidFill>
+                <a:latin typeface="Arial" pitchFamily="34" charset="0"/>
+                <a:ea typeface="Arial" pitchFamily="34" charset="-122"/>
+                <a:cs typeface="Arial" pitchFamily="34" charset="-120"/>
+              </a:rPr>
+              <a:t>QIMMAH RUSSO</a:t>
+            </a:r>
+            <a:endParaRPr lang="en-US" sz="1300" dirty="0"/>
+          </a:p>
+        </p:txBody>
+      </p:sp>
+      <p:sp>
+        <p:nvSpPr>
+          <p:cNvPr id="49" name="Text 27"/>
+          <p:cNvSpPr/>
+          <p:nvPr/>
+        </p:nvSpPr>
+        <p:spPr>
+          <a:xfrm>
+            <a:off x="3459404" y="5577840"/>
+            <a:ext cx="2636444" cy="274320"/>
           </a:xfrm>
           <a:prstGeom prst="rect">
             <a:avLst/>
@@ -3757,46 +3814,7 @@
               <a:buNone/>
             </a:pPr>
             <a:r>
-              <a:rPr lang="en-US" sz="1500" b="1" dirty="0">
-                <a:solidFill>
-                  <a:srgbClr val="FF3EA5"/>
-                </a:solidFill>
-                <a:latin typeface="Arial" pitchFamily="34" charset="0"/>
-                <a:ea typeface="Arial" pitchFamily="34" charset="-122"/>
-                <a:cs typeface="Arial" pitchFamily="34" charset="-120"/>
-              </a:rPr>
-              <a:t>CHLOE AMOUR</a:t>
-            </a:r>
-            <a:endParaRPr lang="en-US" sz="1500" dirty="0"/>
-          </a:p>
-        </p:txBody>
-      </p:sp>
-      <p:sp>
-        <p:nvSpPr>
-          <p:cNvPr id="49" name="Text 27"/>
-          <p:cNvSpPr/>
-          <p:nvPr/>
-        </p:nvSpPr>
-        <p:spPr>
-          <a:xfrm>
-            <a:off x="7854696" y="5806440"/>
-            <a:ext cx="3383280" cy="274320"/>
-          </a:xfrm>
-          <a:prstGeom prst="rect">
-            <a:avLst/>
-          </a:prstGeom>
-          <a:noFill/>
-          <a:ln/>
-        </p:spPr>
-        <p:txBody>
-          <a:bodyPr wrap="square" rtlCol="0" anchor="ctr"/>
-          <a:lstStyle/>
-          <a:p>
-            <a:pPr algn="ctr" indent="0" marL="0">
-              <a:buNone/>
-            </a:pPr>
-            <a:r>
-              <a:rPr lang="en-US" sz="1050" spc="100" kern="0" dirty="0">
+              <a:rPr lang="en-US" sz="1000" spc="100" kern="0" dirty="0">
                 <a:solidFill>
                   <a:srgbClr val="A6A6AE"/>
                 </a:solidFill>
@@ -3804,9 +3822,9 @@
                 <a:ea typeface="Arial" pitchFamily="34" charset="-122"/>
                 <a:cs typeface="Arial" pitchFamily="34" charset="-120"/>
               </a:rPr>
-              <a:t>2.4M FOLLOWERS</a:t>
-            </a:r>
-            <a:endParaRPr lang="en-US" sz="1050" dirty="0"/>
+              <a:t>5M FOLLOWERS</a:t>
+            </a:r>
+            <a:endParaRPr lang="en-US" sz="1000" dirty="0"/>
           </a:p>
         </p:txBody>
       </p:sp>
@@ -3818,8 +3836,8 @@
         </p:nvSpPr>
         <p:spPr>
           <a:xfrm>
-            <a:off x="8933688" y="6135624"/>
-            <a:ext cx="310896" cy="310896"/>
+            <a:off x="4238130" y="5897880"/>
+            <a:ext cx="274320" cy="274320"/>
           </a:xfrm>
           <a:prstGeom prst="ellipse">
             <a:avLst/>
@@ -3846,8 +3864,8 @@
         </p:blipFill>
         <p:spPr>
           <a:xfrm>
-            <a:off x="9002268" y="6204204"/>
-            <a:ext cx="173736" cy="173736"/>
+            <a:off x="4297566" y="5957316"/>
+            <a:ext cx="155448" cy="155448"/>
           </a:xfrm>
           <a:prstGeom prst="rect">
             <a:avLst/>
@@ -3862,8 +3880,8 @@
         </p:nvSpPr>
         <p:spPr>
           <a:xfrm>
-            <a:off x="9390888" y="6135624"/>
-            <a:ext cx="310896" cy="310896"/>
+            <a:off x="4640466" y="5897880"/>
+            <a:ext cx="274320" cy="274320"/>
           </a:xfrm>
           <a:prstGeom prst="ellipse">
             <a:avLst/>
@@ -3890,8 +3908,8 @@
         </p:blipFill>
         <p:spPr>
           <a:xfrm>
-            <a:off x="9459468" y="6204204"/>
-            <a:ext cx="173736" cy="173736"/>
+            <a:off x="4699902" y="5957316"/>
+            <a:ext cx="155448" cy="155448"/>
           </a:xfrm>
           <a:prstGeom prst="rect">
             <a:avLst/>
@@ -3906,8 +3924,8 @@
         </p:nvSpPr>
         <p:spPr>
           <a:xfrm>
-            <a:off x="9848088" y="6135624"/>
-            <a:ext cx="310896" cy="310896"/>
+            <a:off x="5042802" y="5897880"/>
+            <a:ext cx="274320" cy="274320"/>
           </a:xfrm>
           <a:prstGeom prst="ellipse">
             <a:avLst/>
@@ -3934,8 +3952,482 @@
         </p:blipFill>
         <p:spPr>
           <a:xfrm>
-            <a:off x="9916668" y="6204204"/>
-            <a:ext cx="173736" cy="173736"/>
+            <a:off x="5102238" y="5957316"/>
+            <a:ext cx="155448" cy="155448"/>
+          </a:xfrm>
+          <a:prstGeom prst="rect">
+            <a:avLst/>
+          </a:prstGeom>
+        </p:spPr>
+      </p:pic>
+      <p:pic>
+        <p:nvPicPr>
+          <p:cNvPr id="56" name="Image 23" descr="/tmp/claude-0/-home-user-dasdsjfoisdjfoisj-github-io/f756b5b4-9ba5-5f42-afc2-0aa030ec1623/scratchpad/asdeck/assets/av-chloe.png">    </p:cNvPr>
+          <p:cNvPicPr>
+            <a:picLocks noChangeAspect="1"/>
+          </p:cNvPicPr>
+          <p:nvPr/>
+        </p:nvPicPr>
+        <p:blipFill>
+          <a:blip r:embed="rId25"/>
+          <a:stretch>
+            <a:fillRect/>
+          </a:stretch>
+        </p:blipFill>
+        <p:spPr>
+          <a:xfrm>
+            <a:off x="6888289" y="3977640"/>
+            <a:ext cx="1051560" cy="1051560"/>
+          </a:xfrm>
+          <a:prstGeom prst="rect">
+            <a:avLst/>
+          </a:prstGeom>
+        </p:spPr>
+      </p:pic>
+      <p:sp>
+        <p:nvSpPr>
+          <p:cNvPr id="57" name="Text 31"/>
+          <p:cNvSpPr/>
+          <p:nvPr/>
+        </p:nvSpPr>
+        <p:spPr>
+          <a:xfrm>
+            <a:off x="6095848" y="5074920"/>
+            <a:ext cx="2636444" cy="457200"/>
+          </a:xfrm>
+          <a:prstGeom prst="rect">
+            <a:avLst/>
+          </a:prstGeom>
+          <a:noFill/>
+          <a:ln/>
+        </p:spPr>
+        <p:txBody>
+          <a:bodyPr wrap="square" rtlCol="0" anchor="t"/>
+          <a:lstStyle/>
+          <a:p>
+            <a:pPr algn="ctr" indent="0" marL="0">
+              <a:lnSpc>
+                <a:spcPct val="100000"/>
+              </a:lnSpc>
+              <a:buNone/>
+            </a:pPr>
+            <a:r>
+              <a:rPr lang="en-US" sz="1300" b="1" dirty="0">
+                <a:solidFill>
+                  <a:srgbClr val="FF3EA5"/>
+                </a:solidFill>
+                <a:latin typeface="Arial" pitchFamily="34" charset="0"/>
+                <a:ea typeface="Arial" pitchFamily="34" charset="-122"/>
+                <a:cs typeface="Arial" pitchFamily="34" charset="-120"/>
+              </a:rPr>
+              <a:t>CHLOE AMOUR</a:t>
+            </a:r>
+            <a:endParaRPr lang="en-US" sz="1300" dirty="0"/>
+          </a:p>
+        </p:txBody>
+      </p:sp>
+      <p:sp>
+        <p:nvSpPr>
+          <p:cNvPr id="58" name="Text 32"/>
+          <p:cNvSpPr/>
+          <p:nvPr/>
+        </p:nvSpPr>
+        <p:spPr>
+          <a:xfrm>
+            <a:off x="6095848" y="5577840"/>
+            <a:ext cx="2636444" cy="274320"/>
+          </a:xfrm>
+          <a:prstGeom prst="rect">
+            <a:avLst/>
+          </a:prstGeom>
+          <a:noFill/>
+          <a:ln/>
+        </p:spPr>
+        <p:txBody>
+          <a:bodyPr wrap="square" rtlCol="0" anchor="ctr"/>
+          <a:lstStyle/>
+          <a:p>
+            <a:pPr algn="ctr" indent="0" marL="0">
+              <a:buNone/>
+            </a:pPr>
+            <a:r>
+              <a:rPr lang="en-US" sz="1000" spc="100" kern="0" dirty="0">
+                <a:solidFill>
+                  <a:srgbClr val="A6A6AE"/>
+                </a:solidFill>
+                <a:latin typeface="Arial" pitchFamily="34" charset="0"/>
+                <a:ea typeface="Arial" pitchFamily="34" charset="-122"/>
+                <a:cs typeface="Arial" pitchFamily="34" charset="-120"/>
+              </a:rPr>
+              <a:t>2.4M FOLLOWERS</a:t>
+            </a:r>
+            <a:endParaRPr lang="en-US" sz="1000" dirty="0"/>
+          </a:p>
+        </p:txBody>
+      </p:sp>
+      <p:sp>
+        <p:nvSpPr>
+          <p:cNvPr id="59" name="Shape 33"/>
+          <p:cNvSpPr/>
+          <p:nvPr/>
+        </p:nvSpPr>
+        <p:spPr>
+          <a:xfrm>
+            <a:off x="6874574" y="5897880"/>
+            <a:ext cx="274320" cy="274320"/>
+          </a:xfrm>
+          <a:prstGeom prst="ellipse">
+            <a:avLst/>
+          </a:prstGeom>
+          <a:solidFill>
+            <a:srgbClr val="F2F2F2"/>
+          </a:solidFill>
+          <a:ln/>
+        </p:spPr>
+      </p:sp>
+      <p:pic>
+        <p:nvPicPr>
+          <p:cNvPr id="60" name="Image 24" descr="/tmp/claude-0/-home-user-dasdsjfoisdjfoisj-github-io/f756b5b4-9ba5-5f42-afc2-0aa030ec1623/scratchpad/asdeck/assets/ic-x.png">    </p:cNvPr>
+          <p:cNvPicPr>
+            <a:picLocks noChangeAspect="1"/>
+          </p:cNvPicPr>
+          <p:nvPr/>
+        </p:nvPicPr>
+        <p:blipFill>
+          <a:blip r:embed="rId26"/>
+          <a:stretch>
+            <a:fillRect/>
+          </a:stretch>
+        </p:blipFill>
+        <p:spPr>
+          <a:xfrm>
+            <a:off x="6934010" y="5957316"/>
+            <a:ext cx="155448" cy="155448"/>
+          </a:xfrm>
+          <a:prstGeom prst="rect">
+            <a:avLst/>
+          </a:prstGeom>
+        </p:spPr>
+      </p:pic>
+      <p:sp>
+        <p:nvSpPr>
+          <p:cNvPr id="61" name="Shape 34"/>
+          <p:cNvSpPr/>
+          <p:nvPr/>
+        </p:nvSpPr>
+        <p:spPr>
+          <a:xfrm>
+            <a:off x="7276910" y="5897880"/>
+            <a:ext cx="274320" cy="274320"/>
+          </a:xfrm>
+          <a:prstGeom prst="ellipse">
+            <a:avLst/>
+          </a:prstGeom>
+          <a:solidFill>
+            <a:srgbClr val="F2F2F2"/>
+          </a:solidFill>
+          <a:ln/>
+        </p:spPr>
+      </p:sp>
+      <p:pic>
+        <p:nvPicPr>
+          <p:cNvPr id="62" name="Image 25" descr="/tmp/claude-0/-home-user-dasdsjfoisdjfoisj-github-io/f756b5b4-9ba5-5f42-afc2-0aa030ec1623/scratchpad/asdeck/assets/ic-tiktok.png">    </p:cNvPr>
+          <p:cNvPicPr>
+            <a:picLocks noChangeAspect="1"/>
+          </p:cNvPicPr>
+          <p:nvPr/>
+        </p:nvPicPr>
+        <p:blipFill>
+          <a:blip r:embed="rId27"/>
+          <a:stretch>
+            <a:fillRect/>
+          </a:stretch>
+        </p:blipFill>
+        <p:spPr>
+          <a:xfrm>
+            <a:off x="7336346" y="5957316"/>
+            <a:ext cx="155448" cy="155448"/>
+          </a:xfrm>
+          <a:prstGeom prst="rect">
+            <a:avLst/>
+          </a:prstGeom>
+        </p:spPr>
+      </p:pic>
+      <p:sp>
+        <p:nvSpPr>
+          <p:cNvPr id="63" name="Shape 35"/>
+          <p:cNvSpPr/>
+          <p:nvPr/>
+        </p:nvSpPr>
+        <p:spPr>
+          <a:xfrm>
+            <a:off x="7679246" y="5897880"/>
+            <a:ext cx="274320" cy="274320"/>
+          </a:xfrm>
+          <a:prstGeom prst="ellipse">
+            <a:avLst/>
+          </a:prstGeom>
+          <a:solidFill>
+            <a:srgbClr val="F2F2F2"/>
+          </a:solidFill>
+          <a:ln/>
+        </p:spPr>
+      </p:sp>
+      <p:pic>
+        <p:nvPicPr>
+          <p:cNvPr id="64" name="Image 26" descr="/tmp/claude-0/-home-user-dasdsjfoisdjfoisj-github-io/f756b5b4-9ba5-5f42-afc2-0aa030ec1623/scratchpad/asdeck/assets/ic-instagram.png">    </p:cNvPr>
+          <p:cNvPicPr>
+            <a:picLocks noChangeAspect="1"/>
+          </p:cNvPicPr>
+          <p:nvPr/>
+        </p:nvPicPr>
+        <p:blipFill>
+          <a:blip r:embed="rId28"/>
+          <a:stretch>
+            <a:fillRect/>
+          </a:stretch>
+        </p:blipFill>
+        <p:spPr>
+          <a:xfrm>
+            <a:off x="7738682" y="5957316"/>
+            <a:ext cx="155448" cy="155448"/>
+          </a:xfrm>
+          <a:prstGeom prst="rect">
+            <a:avLst/>
+          </a:prstGeom>
+        </p:spPr>
+      </p:pic>
+      <p:pic>
+        <p:nvPicPr>
+          <p:cNvPr id="65" name="Image 27" descr="/tmp/claude-0/-home-user-dasdsjfoisdjfoisj-github-io/f756b5b4-9ba5-5f42-afc2-0aa030ec1623/scratchpad/asdeck/assets/av-zlata.png">    </p:cNvPr>
+          <p:cNvPicPr>
+            <a:picLocks noChangeAspect="1"/>
+          </p:cNvPicPr>
+          <p:nvPr/>
+        </p:nvPicPr>
+        <p:blipFill>
+          <a:blip r:embed="rId29"/>
+          <a:stretch>
+            <a:fillRect/>
+          </a:stretch>
+        </p:blipFill>
+        <p:spPr>
+          <a:xfrm>
+            <a:off x="9524733" y="3977640"/>
+            <a:ext cx="1051560" cy="1051560"/>
+          </a:xfrm>
+          <a:prstGeom prst="rect">
+            <a:avLst/>
+          </a:prstGeom>
+        </p:spPr>
+      </p:pic>
+      <p:sp>
+        <p:nvSpPr>
+          <p:cNvPr id="66" name="Text 36"/>
+          <p:cNvSpPr/>
+          <p:nvPr/>
+        </p:nvSpPr>
+        <p:spPr>
+          <a:xfrm>
+            <a:off x="8732291" y="5074920"/>
+            <a:ext cx="2636444" cy="457200"/>
+          </a:xfrm>
+          <a:prstGeom prst="rect">
+            <a:avLst/>
+          </a:prstGeom>
+          <a:noFill/>
+          <a:ln/>
+        </p:spPr>
+        <p:txBody>
+          <a:bodyPr wrap="square" rtlCol="0" anchor="t"/>
+          <a:lstStyle/>
+          <a:p>
+            <a:pPr algn="ctr" indent="0" marL="0">
+              <a:lnSpc>
+                <a:spcPct val="100000"/>
+              </a:lnSpc>
+              <a:buNone/>
+            </a:pPr>
+            <a:r>
+              <a:rPr lang="en-US" sz="1300" b="1" dirty="0">
+                <a:solidFill>
+                  <a:srgbClr val="FF3EA5"/>
+                </a:solidFill>
+                <a:latin typeface="Arial" pitchFamily="34" charset="0"/>
+                <a:ea typeface="Arial" pitchFamily="34" charset="-122"/>
+                <a:cs typeface="Arial" pitchFamily="34" charset="-120"/>
+              </a:rPr>
+              <a:t>ZLATA SHARVAROK</a:t>
+            </a:r>
+            <a:endParaRPr lang="en-US" sz="1300" dirty="0"/>
+          </a:p>
+        </p:txBody>
+      </p:sp>
+      <p:sp>
+        <p:nvSpPr>
+          <p:cNvPr id="67" name="Text 37"/>
+          <p:cNvSpPr/>
+          <p:nvPr/>
+        </p:nvSpPr>
+        <p:spPr>
+          <a:xfrm>
+            <a:off x="8732291" y="5577840"/>
+            <a:ext cx="2636444" cy="274320"/>
+          </a:xfrm>
+          <a:prstGeom prst="rect">
+            <a:avLst/>
+          </a:prstGeom>
+          <a:noFill/>
+          <a:ln/>
+        </p:spPr>
+        <p:txBody>
+          <a:bodyPr wrap="square" rtlCol="0" anchor="ctr"/>
+          <a:lstStyle/>
+          <a:p>
+            <a:pPr algn="ctr" indent="0" marL="0">
+              <a:buNone/>
+            </a:pPr>
+            <a:r>
+              <a:rPr lang="en-US" sz="1000" spc="100" kern="0" dirty="0">
+                <a:solidFill>
+                  <a:srgbClr val="A6A6AE"/>
+                </a:solidFill>
+                <a:latin typeface="Arial" pitchFamily="34" charset="0"/>
+                <a:ea typeface="Arial" pitchFamily="34" charset="-122"/>
+                <a:cs typeface="Arial" pitchFamily="34" charset="-120"/>
+              </a:rPr>
+              <a:t>1M FOLLOWERS</a:t>
+            </a:r>
+            <a:endParaRPr lang="en-US" sz="1000" dirty="0"/>
+          </a:p>
+        </p:txBody>
+      </p:sp>
+      <p:sp>
+        <p:nvSpPr>
+          <p:cNvPr id="68" name="Shape 38"/>
+          <p:cNvSpPr/>
+          <p:nvPr/>
+        </p:nvSpPr>
+        <p:spPr>
+          <a:xfrm>
+            <a:off x="9511017" y="5897880"/>
+            <a:ext cx="274320" cy="274320"/>
+          </a:xfrm>
+          <a:prstGeom prst="ellipse">
+            <a:avLst/>
+          </a:prstGeom>
+          <a:solidFill>
+            <a:srgbClr val="F2F2F2"/>
+          </a:solidFill>
+          <a:ln/>
+        </p:spPr>
+      </p:sp>
+      <p:pic>
+        <p:nvPicPr>
+          <p:cNvPr id="69" name="Image 28" descr="/tmp/claude-0/-home-user-dasdsjfoisdjfoisj-github-io/f756b5b4-9ba5-5f42-afc2-0aa030ec1623/scratchpad/asdeck/assets/ic-x.png">    </p:cNvPr>
+          <p:cNvPicPr>
+            <a:picLocks noChangeAspect="1"/>
+          </p:cNvPicPr>
+          <p:nvPr/>
+        </p:nvPicPr>
+        <p:blipFill>
+          <a:blip r:embed="rId30"/>
+          <a:stretch>
+            <a:fillRect/>
+          </a:stretch>
+        </p:blipFill>
+        <p:spPr>
+          <a:xfrm>
+            <a:off x="9570453" y="5957316"/>
+            <a:ext cx="155448" cy="155448"/>
+          </a:xfrm>
+          <a:prstGeom prst="rect">
+            <a:avLst/>
+          </a:prstGeom>
+        </p:spPr>
+      </p:pic>
+      <p:sp>
+        <p:nvSpPr>
+          <p:cNvPr id="70" name="Shape 39"/>
+          <p:cNvSpPr/>
+          <p:nvPr/>
+        </p:nvSpPr>
+        <p:spPr>
+          <a:xfrm>
+            <a:off x="9913353" y="5897880"/>
+            <a:ext cx="274320" cy="274320"/>
+          </a:xfrm>
+          <a:prstGeom prst="ellipse">
+            <a:avLst/>
+          </a:prstGeom>
+          <a:solidFill>
+            <a:srgbClr val="F2F2F2"/>
+          </a:solidFill>
+          <a:ln/>
+        </p:spPr>
+      </p:sp>
+      <p:pic>
+        <p:nvPicPr>
+          <p:cNvPr id="71" name="Image 29" descr="/tmp/claude-0/-home-user-dasdsjfoisdjfoisj-github-io/f756b5b4-9ba5-5f42-afc2-0aa030ec1623/scratchpad/asdeck/assets/ic-tiktok.png">    </p:cNvPr>
+          <p:cNvPicPr>
+            <a:picLocks noChangeAspect="1"/>
+          </p:cNvPicPr>
+          <p:nvPr/>
+        </p:nvPicPr>
+        <p:blipFill>
+          <a:blip r:embed="rId31"/>
+          <a:stretch>
+            <a:fillRect/>
+          </a:stretch>
+        </p:blipFill>
+        <p:spPr>
+          <a:xfrm>
+            <a:off x="9972789" y="5957316"/>
+            <a:ext cx="155448" cy="155448"/>
+          </a:xfrm>
+          <a:prstGeom prst="rect">
+            <a:avLst/>
+          </a:prstGeom>
+        </p:spPr>
+      </p:pic>
+      <p:sp>
+        <p:nvSpPr>
+          <p:cNvPr id="72" name="Shape 40"/>
+          <p:cNvSpPr/>
+          <p:nvPr/>
+        </p:nvSpPr>
+        <p:spPr>
+          <a:xfrm>
+            <a:off x="10315689" y="5897880"/>
+            <a:ext cx="274320" cy="274320"/>
+          </a:xfrm>
+          <a:prstGeom prst="ellipse">
+            <a:avLst/>
+          </a:prstGeom>
+          <a:solidFill>
+            <a:srgbClr val="F2F2F2"/>
+          </a:solidFill>
+          <a:ln/>
+        </p:spPr>
+      </p:sp>
+      <p:pic>
+        <p:nvPicPr>
+          <p:cNvPr id="73" name="Image 30" descr="/tmp/claude-0/-home-user-dasdsjfoisdjfoisj-github-io/f756b5b4-9ba5-5f42-afc2-0aa030ec1623/scratchpad/asdeck/assets/ic-instagram.png">    </p:cNvPr>
+          <p:cNvPicPr>
+            <a:picLocks noChangeAspect="1"/>
+          </p:cNvPicPr>
+          <p:nvPr/>
+        </p:nvPicPr>
+        <p:blipFill>
+          <a:blip r:embed="rId32"/>
+          <a:stretch>
+            <a:fillRect/>
+          </a:stretch>
+        </p:blipFill>
+        <p:spPr>
+          <a:xfrm>
+            <a:off x="10375125" y="5957316"/>
+            <a:ext cx="155448" cy="155448"/>
           </a:xfrm>
           <a:prstGeom prst="rect">
             <a:avLst/>
@@ -4986,7 +5478,7 @@
                 <a:ea typeface="Arial" pitchFamily="34" charset="-122"/>
                 <a:cs typeface="Arial" pitchFamily="34" charset="-120"/>
               </a:rPr>
-              <a:t>33M+</a:t>
+              <a:t>79M+</a:t>
             </a:r>
             <a:endParaRPr lang="en-US" sz="4800" dirty="0"/>
           </a:p>
@@ -5139,7 +5631,7 @@
                 <a:ea typeface="Arial" pitchFamily="34" charset="-122"/>
                 <a:cs typeface="Arial" pitchFamily="34" charset="-120"/>
               </a:rPr>
-              <a:t>6</a:t>
+              <a:t>8</a:t>
             </a:r>
             <a:endParaRPr lang="en-US" sz="4800" dirty="0"/>
           </a:p>

</xml_diff>